<commit_message>
Refine triage metrics and honest evaluation workflow
</commit_message>
<xml_diff>
--- a/presentation.pptx
+++ b/presentation.pptx
@@ -3301,7 +3301,7 @@
               </a:defRPr>
             </a:pPr>
             <a:r>
-              <a:t>Results &amp; validation (real numbers, seed 42, from metrics.json)</a:t>
+              <a:t>Results &amp; validation (real numbers from metrics.json)</a:t>
             </a:r>
           </a:p>
         </p:txBody>
@@ -3339,7 +3339,7 @@
               </a:defRPr>
             </a:pPr>
             <a:r>
-              <a:t>Legacy manual recall (critical): 0.333 (FN 20)</a:t>
+              <a:t>Seed 42 (tuning): legacy recall 0.333 → final 0.667</a:t>
             </a:r>
           </a:p>
           <a:p>
@@ -3354,7 +3354,7 @@
               </a:defRPr>
             </a:pPr>
             <a:r>
-              <a:t>Executor-only recall: 0.733 — automation alone is NOT enough</a:t>
+              <a:t>Eval seeds 7+99: final recall 0.755, precision 0.249</a:t>
             </a:r>
           </a:p>
           <a:p>
@@ -3369,7 +3369,7 @@
               </a:defRPr>
             </a:pPr>
             <a:r>
-              <a:t>Executor + Critic recall: 0.733 (CI 95%: [0.567, 0.897])</a:t>
+              <a:t>Seed 99 final: recall 0.818, precision 0.318</a:t>
             </a:r>
           </a:p>
           <a:p>
@@ -3384,7 +3384,7 @@
               </a:defRPr>
             </a:pPr>
             <a:r>
-              <a:t>Missed criticals caught: 104 · Immediate items: 30</a:t>
+              <a:t>missed_caught: 13/8/16 (seeds 42/7/99) · false alarms: 73/82/58</a:t>
             </a:r>
           </a:p>
           <a:p>
@@ -3399,22 +3399,7 @@
               </a:defRPr>
             </a:pPr>
             <a:r>
-              <a:t>Interacting share: 3.3% · Escalated: 0.000% · MONITOR share: 25.7%</a:t>
-            </a:r>
-          </a:p>
-          <a:p>
-            <a:pPr>
-              <a:spcAft>
-                <a:spcPts val="600"/>
-              </a:spcAft>
-              <a:defRPr sz="1400">
-                <a:solidFill>
-                  <a:srgbClr val="5A5A5A"/>
-                </a:solidFill>
-              </a:defRPr>
-            </a:pPr>
-            <a:r>
-              <a:t>Planted missed-criticals caught: 73.3% · Validation errors: 0 · Runtime: 0.090 s</a:t>
+              <a:t>Interacting ~3-5% · Rework: 1 iter, all resolved · Validation errors: 0 · Runtime &lt;0.2 s</a:t>
             </a:r>
           </a:p>
         </p:txBody>
@@ -3558,7 +3543,7 @@
               </a:defRPr>
             </a:pPr>
             <a:r>
-              <a:t>Static thresholds; no learning from engineer feedback yet</a:t>
+              <a:t>Low precision / over-triage — precision 0.249 (target &gt;= 0.40 not reached); 73-58 false alarms per run from ILI noise</a:t>
             </a:r>
           </a:p>
           <a:p>
@@ -3573,7 +3558,7 @@
               </a:defRPr>
             </a:pPr>
             <a:r>
-              <a:t>Single-machine PoC: no auth, audit DB, or crew scheduling</a:t>
+              <a:t>Rework convergence partly by design (shared rule family); independent learned Critic is future scope</a:t>
             </a:r>
           </a:p>
           <a:p>
@@ -3588,7 +3573,7 @@
               </a:defRPr>
             </a:pPr>
             <a:r>
-              <a:t>Ground truth model: independent hand-written rule model with assumed noise model</a:t>
+              <a:t>Static thresholds; no learning from engineer feedback; single-machine PoC</a:t>
             </a:r>
           </a:p>
         </p:txBody>
@@ -3717,7 +3702,7 @@
               </a:defRPr>
             </a:pPr>
             <a:r>
-              <a:t>Conclusion: critic-guarded agents lift critical recall 0.333 → 0.733 with full traceability — a viable second pair of eyes.</a:t>
+              <a:t>Conclusion: critic-guarded agents lift critical recall 0.333 → 0.667 with full traceability — a viable second pair of eyes.</a:t>
             </a:r>
           </a:p>
         </p:txBody>
@@ -3990,7 +3975,7 @@
               </a:defRPr>
             </a:pPr>
             <a:r>
-              <a:t>Legacy labels in our synthetic run miss 20/30 criticals (recall 0.333)</a:t>
+              <a:t>Legacy labels in our synthetic run have recall 0.333 — many criticals missed</a:t>
             </a:r>
           </a:p>
           <a:p>
@@ -4482,7 +4467,7 @@
               </a:defRPr>
             </a:pPr>
             <a:r>
-              <a:t>This run: 1 rework iteration(s), 0 final upgrade(s), 0 escalated</a:t>
+              <a:t>This run: 1 rework iteration(s), 0 objections, 0 escalated</a:t>
             </a:r>
           </a:p>
           <a:p>
@@ -4812,7 +4797,7 @@
               </a:defRPr>
             </a:pPr>
             <a:r>
-              <a:t>Seed 42 · full 300-anomaly run in 0.090 s (budget 30 s)</a:t>
+              <a:t>Seed 42 · full 300-anomaly run in 0 s (budget 30 s)</a:t>
             </a:r>
           </a:p>
         </p:txBody>

</xml_diff>